<commit_message>
GTM framing: cost per qualified lead, sample outreach slide
</commit_message>
<xml_diff>
--- a/docs/whitespace-deck.pptx
+++ b/docs/whitespace-deck.pptx
@@ -12,9 +12,10 @@
     <p:sldId id="260" r:id="rId6"/>
     <p:sldId id="261" r:id="rId7"/>
     <p:sldId id="262" r:id="rId8"/>
+    <p:sldId id="263" r:id="rId9"/>
   </p:sldIdLst>
   <p:notesMasterIdLst>
-    <p:notesMasterId r:id="rId9"/>
+    <p:notesMasterId r:id="rId10"/>
   </p:notesMasterIdLst>
   <p:sldSz cx="12192000" cy="6858000"/>
   <p:notesSz cx="6858000" cy="12192000"/>
@@ -772,7 +773,7 @@
           <a:p>
             <a:r>
               <a:rPr lang="en-US" dirty="0"/>
-              <a:t>This split is also what makes the dashboard sliders work: the judgement is fixed, the weighting is not.</a:t>
+              <a:t>The leverage signal is not just a score, it decides what the first sentence of the email says. That is the difference between personalization and mail merge.</a:t>
             </a:r>
             <a:endParaRPr lang="en-US" dirty="0"/>
           </a:p>
@@ -860,7 +861,7 @@
           <a:p>
             <a:r>
               <a:rPr lang="en-US" dirty="0"/>
-              <a:t>A writer checking its own work agrees with itself, which is why it is two separate calls. If the verifier fails to answer, the draft is flagged rather than passed.</a:t>
+              <a:t>This split is also what makes the dashboard sliders work: the judgement is fixed, the weighting is not.</a:t>
             </a:r>
             <a:endParaRPr lang="en-US" dirty="0"/>
           </a:p>
@@ -948,7 +949,7 @@
           <a:p>
             <a:r>
               <a:rPr lang="en-US" dirty="0"/>
-              <a:t>Clay is specified with its field map and the four steps to make it live. Precedence is already resolved: a Clay figure outranks a web reading but not a company's own published figure.</a:t>
+              <a:t>A writer checking its own work agrees with itself, which is why it is two separate calls. If the verifier fails to answer, the draft is flagged rather than passed.</a:t>
             </a:r>
             <a:endParaRPr lang="en-US" dirty="0"/>
           </a:p>
@@ -1036,7 +1037,7 @@
           <a:p>
             <a:r>
               <a:rPr lang="en-US" dirty="0"/>
-              <a:t>Naming the limits is the point. A system that cannot say what it does not know is one a sales team stops trusting after the first bad lead.</a:t>
+              <a:t>Clay is specified with its field map and the four steps to make it live. Precedence is already resolved: a Clay figure outranks a web reading but not a company's own published figure.</a:t>
             </a:r>
             <a:endParaRPr lang="en-US" dirty="0"/>
           </a:p>
@@ -1060,6 +1061,94 @@
             <a:fld id="{F7021451-1387-4CA6-816F-3879F97B5CBC}" type="slidenum">
               <a:rPr lang="en-US"/>
               <a:t>7</a:t>
+            </a:fld>
+            <a:endParaRPr lang="en-US"/>
+          </a:p>
+        </p:txBody>
+      </p:sp>
+    </p:spTree>
+    <p:extLst>
+      <p:ext uri="{BB962C8B-B14F-4D97-AF65-F5344CB8AC3E}">
+        <p14:creationId xmlns:p14="http://schemas.microsoft.com/office/powerpoint/2010/main" val="1024086991"/>
+      </p:ext>
+    </p:extLst>
+  </p:cSld>
+  <p:clrMapOvr>
+    <a:masterClrMapping/>
+  </p:clrMapOvr>
+</p:notes>
+</file>
+
+<file path=ppt/notesSlides/notesSlide8.xml><?xml version="1.0" encoding="utf-8"?>
+<p:notes xmlns:a="http://schemas.openxmlformats.org/drawingml/2006/main" xmlns:r="http://schemas.openxmlformats.org/officeDocument/2006/relationships" xmlns:p="http://schemas.openxmlformats.org/presentationml/2006/main">
+  <p:cSld>
+    <p:spTree>
+      <p:nvGrpSpPr>
+        <p:cNvPr id="1" name=""/>
+        <p:cNvGrpSpPr/>
+        <p:nvPr/>
+      </p:nvGrpSpPr>
+      <p:grpSpPr>
+        <a:xfrm>
+          <a:off x="0" y="0"/>
+          <a:ext cx="0" cy="0"/>
+          <a:chOff x="0" y="0"/>
+          <a:chExt cx="0" cy="0"/>
+        </a:xfrm>
+      </p:grpSpPr>
+      <p:sp>
+        <p:nvSpPr>
+          <p:cNvPr id="2" name="Slide Image Placeholder 1"/>
+          <p:cNvSpPr>
+            <a:spLocks noGrp="1" noRot="1" noChangeAspect="1"/>
+          </p:cNvSpPr>
+          <p:nvPr>
+            <p:ph type="sldImg"/>
+          </p:nvPr>
+        </p:nvSpPr>
+        <p:spPr/>
+      </p:sp>
+      <p:sp>
+        <p:nvSpPr>
+          <p:cNvPr id="3" name="Notes Placeholder 2"/>
+          <p:cNvSpPr>
+            <a:spLocks noGrp="1"/>
+          </p:cNvSpPr>
+          <p:nvPr>
+            <p:ph type="body" idx="1"/>
+          </p:nvPr>
+        </p:nvSpPr>
+        <p:spPr/>
+        <p:txBody>
+          <a:bodyPr/>
+          <a:lstStyle/>
+          <a:p>
+            <a:r>
+              <a:rPr lang="en-US" dirty="0"/>
+              <a:t>Naming the limits is the point. A system that cannot say what it does not know is one a sales team stops trusting after the first bad lead.</a:t>
+            </a:r>
+            <a:endParaRPr lang="en-US" dirty="0"/>
+          </a:p>
+        </p:txBody>
+      </p:sp>
+      <p:sp>
+        <p:nvSpPr>
+          <p:cNvPr id="4" name="Slide Number Placeholder 3"/>
+          <p:cNvSpPr>
+            <a:spLocks noGrp="1"/>
+          </p:cNvSpPr>
+          <p:nvPr>
+            <p:ph type="sldNum" sz="quarter" idx="10"/>
+          </p:nvPr>
+        </p:nvSpPr>
+        <p:spPr/>
+        <p:txBody>
+          <a:bodyPr/>
+          <a:lstStyle/>
+          <a:p>
+            <a:fld id="{F7021451-1387-4CA6-816F-3879F97B5CBC}" type="slidenum">
+              <a:rPr lang="en-US"/>
+              <a:t>8</a:t>
             </a:fld>
             <a:endParaRPr lang="en-US"/>
           </a:p>
@@ -1552,23 +1641,23 @@
         <p:spPr>
           <a:xfrm>
             <a:off x="777240" y="5349240"/>
-            <a:ext cx="1645920" cy="457200"/>
-          </a:xfrm>
-          <a:prstGeom prst="rect">
-            <a:avLst/>
-          </a:prstGeom>
-          <a:noFill/>
-          <a:ln/>
-        </p:spPr>
-        <p:txBody>
-          <a:bodyPr wrap="square" lIns="0" tIns="0" rIns="0" bIns="0" rtlCol="0" anchor="ctr"/>
-          <a:lstStyle/>
-          <a:p>
-            <a:pPr indent="0" marL="0">
-              <a:buNone/>
-            </a:pPr>
-            <a:r>
-              <a:rPr lang="en-US" sz="3000" dirty="0">
+            <a:ext cx="2103120" cy="457200"/>
+          </a:xfrm>
+          <a:prstGeom prst="rect">
+            <a:avLst/>
+          </a:prstGeom>
+          <a:noFill/>
+          <a:ln/>
+        </p:spPr>
+        <p:txBody>
+          <a:bodyPr wrap="square" lIns="0" tIns="0" rIns="0" bIns="0" rtlCol="0" anchor="ctr"/>
+          <a:lstStyle/>
+          <a:p>
+            <a:pPr indent="0" marL="0">
+              <a:buNone/>
+            </a:pPr>
+            <a:r>
+              <a:rPr lang="en-US" sz="2800" dirty="0">
                 <a:solidFill>
                   <a:srgbClr val="FFFFFF"/>
                 </a:solidFill>
@@ -1576,9 +1665,9 @@
                 <a:ea typeface="Courier New" pitchFamily="34" charset="-122"/>
                 <a:cs typeface="Courier New" pitchFamily="34" charset="-120"/>
               </a:rPr>
-              <a:t>$11</a:t>
-            </a:r>
-            <a:endParaRPr lang="en-US" sz="3000" dirty="0"/>
+              <a:t>$0.42</a:t>
+            </a:r>
+            <a:endParaRPr lang="en-US" sz="2800" dirty="0"/>
           </a:p>
         </p:txBody>
       </p:sp>
@@ -1591,7 +1680,7 @@
         <p:spPr>
           <a:xfrm>
             <a:off x="777240" y="5806440"/>
-            <a:ext cx="1645920" cy="274320"/>
+            <a:ext cx="2103120" cy="274320"/>
           </a:xfrm>
           <a:prstGeom prst="rect">
             <a:avLst/>
@@ -1615,7 +1704,7 @@
                 <a:ea typeface="Courier New" pitchFamily="34" charset="-122"/>
                 <a:cs typeface="Courier New" pitchFamily="34" charset="-120"/>
               </a:rPr>
-              <a:t>one full run</a:t>
+              <a:t>per qualified lead</a:t>
             </a:r>
             <a:endParaRPr lang="en-US" sz="1050" dirty="0"/>
           </a:p>
@@ -1629,24 +1718,24 @@
         </p:nvSpPr>
         <p:spPr>
           <a:xfrm>
-            <a:off x="2560320" y="5349240"/>
-            <a:ext cx="1645920" cy="457200"/>
-          </a:xfrm>
-          <a:prstGeom prst="rect">
-            <a:avLst/>
-          </a:prstGeom>
-          <a:noFill/>
-          <a:ln/>
-        </p:spPr>
-        <p:txBody>
-          <a:bodyPr wrap="square" lIns="0" tIns="0" rIns="0" bIns="0" rtlCol="0" anchor="ctr"/>
-          <a:lstStyle/>
-          <a:p>
-            <a:pPr indent="0" marL="0">
-              <a:buNone/>
-            </a:pPr>
-            <a:r>
-              <a:rPr lang="en-US" sz="3000" dirty="0">
+            <a:off x="3108960" y="5349240"/>
+            <a:ext cx="2103120" cy="457200"/>
+          </a:xfrm>
+          <a:prstGeom prst="rect">
+            <a:avLst/>
+          </a:prstGeom>
+          <a:noFill/>
+          <a:ln/>
+        </p:spPr>
+        <p:txBody>
+          <a:bodyPr wrap="square" lIns="0" tIns="0" rIns="0" bIns="0" rtlCol="0" anchor="ctr"/>
+          <a:lstStyle/>
+          <a:p>
+            <a:pPr indent="0" marL="0">
+              <a:buNone/>
+            </a:pPr>
+            <a:r>
+              <a:rPr lang="en-US" sz="2800" dirty="0">
                 <a:solidFill>
                   <a:srgbClr val="FFFFFF"/>
                 </a:solidFill>
@@ -1654,9 +1743,9 @@
                 <a:ea typeface="Courier New" pitchFamily="34" charset="-122"/>
                 <a:cs typeface="Courier New" pitchFamily="34" charset="-120"/>
               </a:rPr>
-              <a:t>$0</a:t>
-            </a:r>
-            <a:endParaRPr lang="en-US" sz="3000" dirty="0"/>
+              <a:t>26</a:t>
+            </a:r>
+            <a:endParaRPr lang="en-US" sz="2800" dirty="0"/>
           </a:p>
         </p:txBody>
       </p:sp>
@@ -1668,8 +1757,8 @@
         </p:nvSpPr>
         <p:spPr>
           <a:xfrm>
-            <a:off x="2560320" y="5806440"/>
-            <a:ext cx="1645920" cy="274320"/>
+            <a:off x="3108960" y="5806440"/>
+            <a:ext cx="2103120" cy="274320"/>
           </a:xfrm>
           <a:prstGeom prst="rect">
             <a:avLst/>
@@ -1693,7 +1782,7 @@
                 <a:ea typeface="Courier New" pitchFamily="34" charset="-122"/>
                 <a:cs typeface="Courier New" pitchFamily="34" charset="-120"/>
               </a:rPr>
-              <a:t>every rerun</a:t>
+              <a:t>with drafted email</a:t>
             </a:r>
             <a:endParaRPr lang="en-US" sz="1050" dirty="0"/>
           </a:p>
@@ -1707,24 +1796,24 @@
         </p:nvSpPr>
         <p:spPr>
           <a:xfrm>
-            <a:off x="4343400" y="5349240"/>
-            <a:ext cx="1645920" cy="457200"/>
-          </a:xfrm>
-          <a:prstGeom prst="rect">
-            <a:avLst/>
-          </a:prstGeom>
-          <a:noFill/>
-          <a:ln/>
-        </p:spPr>
-        <p:txBody>
-          <a:bodyPr wrap="square" lIns="0" tIns="0" rIns="0" bIns="0" rtlCol="0" anchor="ctr"/>
-          <a:lstStyle/>
-          <a:p>
-            <a:pPr indent="0" marL="0">
-              <a:buNone/>
-            </a:pPr>
-            <a:r>
-              <a:rPr lang="en-US" sz="3000" dirty="0">
+            <a:off x="5440680" y="5349240"/>
+            <a:ext cx="2103120" cy="457200"/>
+          </a:xfrm>
+          <a:prstGeom prst="rect">
+            <a:avLst/>
+          </a:prstGeom>
+          <a:noFill/>
+          <a:ln/>
+        </p:spPr>
+        <p:txBody>
+          <a:bodyPr wrap="square" lIns="0" tIns="0" rIns="0" bIns="0" rtlCol="0" anchor="ctr"/>
+          <a:lstStyle/>
+          <a:p>
+            <a:pPr indent="0" marL="0">
+              <a:buNone/>
+            </a:pPr>
+            <a:r>
+              <a:rPr lang="en-US" sz="2800" dirty="0">
                 <a:solidFill>
                   <a:srgbClr val="FFFFFF"/>
                 </a:solidFill>
@@ -1732,9 +1821,9 @@
                 <a:ea typeface="Courier New" pitchFamily="34" charset="-122"/>
                 <a:cs typeface="Courier New" pitchFamily="34" charset="-120"/>
               </a:rPr>
-              <a:t>6</a:t>
-            </a:r>
-            <a:endParaRPr lang="en-US" sz="3000" dirty="0"/>
+              <a:t>~2 days</a:t>
+            </a:r>
+            <a:endParaRPr lang="en-US" sz="2800" dirty="0"/>
           </a:p>
         </p:txBody>
       </p:sp>
@@ -1746,8 +1835,8 @@
         </p:nvSpPr>
         <p:spPr>
           <a:xfrm>
-            <a:off x="4343400" y="5806440"/>
-            <a:ext cx="1645920" cy="274320"/>
+            <a:off x="5440680" y="5806440"/>
+            <a:ext cx="2103120" cy="274320"/>
           </a:xfrm>
           <a:prstGeom prst="rect">
             <a:avLst/>
@@ -1771,7 +1860,7 @@
                 <a:ea typeface="Courier New" pitchFamily="34" charset="-122"/>
                 <a:cs typeface="Courier New" pitchFamily="34" charset="-120"/>
               </a:rPr>
-              <a:t>agents</a:t>
+              <a:t>of manual work</a:t>
             </a:r>
             <a:endParaRPr lang="en-US" sz="1050" dirty="0"/>
           </a:p>
@@ -3471,6 +3560,635 @@
     <p:bg>
       <p:bgPr>
         <a:solidFill>
+          <a:srgbClr val="FFFFFF"/>
+        </a:solidFill>
+      </p:bgPr>
+    </p:bg>
+    <p:spTree>
+      <p:nvGrpSpPr>
+        <p:cNvPr id="1" name=""/>
+        <p:cNvGrpSpPr/>
+        <p:nvPr/>
+      </p:nvGrpSpPr>
+      <p:grpSpPr>
+        <a:xfrm>
+          <a:off x="0" y="0"/>
+          <a:ext cx="0" cy="0"/>
+          <a:chOff x="0" y="0"/>
+          <a:chExt cx="0" cy="0"/>
+        </a:xfrm>
+      </p:grpSpPr>
+      <p:sp>
+        <p:nvSpPr>
+          <p:cNvPr id="2" name="Text 0"/>
+          <p:cNvSpPr/>
+          <p:nvPr/>
+        </p:nvSpPr>
+        <p:spPr>
+          <a:xfrm>
+            <a:off x="777240" y="502920"/>
+            <a:ext cx="7315200" cy="237744"/>
+          </a:xfrm>
+          <a:prstGeom prst="rect">
+            <a:avLst/>
+          </a:prstGeom>
+          <a:noFill/>
+          <a:ln/>
+        </p:spPr>
+        <p:txBody>
+          <a:bodyPr wrap="square" lIns="0" tIns="0" rIns="0" bIns="0" rtlCol="0" anchor="ctr"/>
+          <a:lstStyle/>
+          <a:p>
+            <a:pPr indent="0" marL="0">
+              <a:buNone/>
+            </a:pPr>
+            <a:r>
+              <a:rPr lang="en-US" sz="1050" spc="160" kern="0" dirty="0">
+                <a:solidFill>
+                  <a:srgbClr val="7D848D"/>
+                </a:solidFill>
+                <a:latin typeface="Courier New" pitchFamily="34" charset="0"/>
+                <a:ea typeface="Courier New" pitchFamily="34" charset="-122"/>
+                <a:cs typeface="Courier New" pitchFamily="34" charset="-120"/>
+              </a:rPr>
+              <a:t>WHAT THE AGENT ACTUALLY WRITES</a:t>
+            </a:r>
+            <a:endParaRPr lang="en-US" sz="1050" dirty="0"/>
+          </a:p>
+        </p:txBody>
+      </p:sp>
+      <p:sp>
+        <p:nvSpPr>
+          <p:cNvPr id="3" name="Text 1"/>
+          <p:cNvSpPr/>
+          <p:nvPr/>
+        </p:nvSpPr>
+        <p:spPr>
+          <a:xfrm>
+            <a:off x="777240" y="822960"/>
+            <a:ext cx="10634472" cy="914400"/>
+          </a:xfrm>
+          <a:prstGeom prst="rect">
+            <a:avLst/>
+          </a:prstGeom>
+          <a:noFill/>
+          <a:ln/>
+        </p:spPr>
+        <p:txBody>
+          <a:bodyPr wrap="square" lIns="0" tIns="0" rIns="0" bIns="0" rtlCol="0" anchor="ctr"/>
+          <a:lstStyle/>
+          <a:p>
+            <a:pPr indent="0" marL="0">
+              <a:buNone/>
+            </a:pPr>
+            <a:r>
+              <a:rPr lang="en-US" sz="3100" b="1" dirty="0">
+                <a:solidFill>
+                  <a:srgbClr val="14161A"/>
+                </a:solidFill>
+                <a:latin typeface="Arial" pitchFamily="34" charset="0"/>
+                <a:ea typeface="Arial" pitchFamily="34" charset="-122"/>
+                <a:cs typeface="Arial" pitchFamily="34" charset="-120"/>
+              </a:rPr>
+              <a:t>Each signal produces a different opening line</a:t>
+            </a:r>
+            <a:endParaRPr lang="en-US" sz="3100" dirty="0"/>
+          </a:p>
+        </p:txBody>
+      </p:sp>
+      <p:sp>
+        <p:nvSpPr>
+          <p:cNvPr id="4" name="Shape 2"/>
+          <p:cNvSpPr/>
+          <p:nvPr/>
+        </p:nvSpPr>
+        <p:spPr>
+          <a:xfrm>
+            <a:off x="777240" y="1783080"/>
+            <a:ext cx="3291840" cy="3246120"/>
+          </a:xfrm>
+          <a:prstGeom prst="rect">
+            <a:avLst/>
+          </a:prstGeom>
+          <a:solidFill>
+            <a:srgbClr val="F2F3F0"/>
+          </a:solidFill>
+          <a:ln w="9525">
+            <a:solidFill>
+              <a:srgbClr val="D6D9D3"/>
+            </a:solidFill>
+            <a:prstDash val="solid"/>
+          </a:ln>
+        </p:spPr>
+      </p:sp>
+      <p:sp>
+        <p:nvSpPr>
+          <p:cNvPr id="5" name="Text 3"/>
+          <p:cNvSpPr/>
+          <p:nvPr/>
+        </p:nvSpPr>
+        <p:spPr>
+          <a:xfrm>
+            <a:off x="1033272" y="1993392"/>
+            <a:ext cx="2834640" cy="274320"/>
+          </a:xfrm>
+          <a:prstGeom prst="rect">
+            <a:avLst/>
+          </a:prstGeom>
+          <a:noFill/>
+          <a:ln/>
+        </p:spPr>
+        <p:txBody>
+          <a:bodyPr wrap="square" lIns="0" tIns="0" rIns="0" bIns="0" rtlCol="0" anchor="ctr"/>
+          <a:lstStyle/>
+          <a:p>
+            <a:pPr indent="0" marL="0">
+              <a:buNone/>
+            </a:pPr>
+            <a:r>
+              <a:rPr lang="en-US" sz="950" spc="120" kern="0" dirty="0">
+                <a:solidFill>
+                  <a:srgbClr val="4B3BD6"/>
+                </a:solidFill>
+                <a:latin typeface="Courier New" pitchFamily="34" charset="0"/>
+                <a:ea typeface="Courier New" pitchFamily="34" charset="-122"/>
+                <a:cs typeface="Courier New" pitchFamily="34" charset="-120"/>
+              </a:rPr>
+              <a:t>INCUMBENT ABSENCE</a:t>
+            </a:r>
+            <a:endParaRPr lang="en-US" sz="950" dirty="0"/>
+          </a:p>
+        </p:txBody>
+      </p:sp>
+      <p:sp>
+        <p:nvSpPr>
+          <p:cNvPr id="6" name="Text 4"/>
+          <p:cNvSpPr/>
+          <p:nvPr/>
+        </p:nvSpPr>
+        <p:spPr>
+          <a:xfrm>
+            <a:off x="1033272" y="2286000"/>
+            <a:ext cx="2834640" cy="292608"/>
+          </a:xfrm>
+          <a:prstGeom prst="rect">
+            <a:avLst/>
+          </a:prstGeom>
+          <a:noFill/>
+          <a:ln/>
+        </p:spPr>
+        <p:txBody>
+          <a:bodyPr wrap="square" lIns="0" tIns="0" rIns="0" bIns="0" rtlCol="0" anchor="ctr"/>
+          <a:lstStyle/>
+          <a:p>
+            <a:pPr indent="0" marL="0">
+              <a:buNone/>
+            </a:pPr>
+            <a:r>
+              <a:rPr lang="en-US" sz="1500" b="1" dirty="0">
+                <a:solidFill>
+                  <a:srgbClr val="14161A"/>
+                </a:solidFill>
+                <a:latin typeface="Arial" pitchFamily="34" charset="0"/>
+                <a:ea typeface="Arial" pitchFamily="34" charset="-122"/>
+                <a:cs typeface="Arial" pitchFamily="34" charset="-120"/>
+              </a:rPr>
+              <a:t>ORAFOL Americas</a:t>
+            </a:r>
+            <a:endParaRPr lang="en-US" sz="1500" dirty="0"/>
+          </a:p>
+        </p:txBody>
+      </p:sp>
+      <p:sp>
+        <p:nvSpPr>
+          <p:cNvPr id="7" name="Text 5"/>
+          <p:cNvSpPr/>
+          <p:nvPr/>
+        </p:nvSpPr>
+        <p:spPr>
+          <a:xfrm>
+            <a:off x="1033272" y="2670048"/>
+            <a:ext cx="2788920" cy="2194560"/>
+          </a:xfrm>
+          <a:prstGeom prst="rect">
+            <a:avLst/>
+          </a:prstGeom>
+          <a:noFill/>
+          <a:ln/>
+        </p:spPr>
+        <p:txBody>
+          <a:bodyPr wrap="square" lIns="0" tIns="0" rIns="0" bIns="0" rtlCol="0" anchor="ctr"/>
+          <a:lstStyle/>
+          <a:p>
+            <a:pPr indent="0" marL="0">
+              <a:lnSpc>
+                <a:spcPts val="1650"/>
+              </a:lnSpc>
+              <a:buNone/>
+            </a:pPr>
+            <a:r>
+              <a:rPr lang="en-US" sz="1200" dirty="0">
+                <a:solidFill>
+                  <a:srgbClr val="4A5058"/>
+                </a:solidFill>
+                <a:latin typeface="Arial" pitchFamily="34" charset="0"/>
+                <a:ea typeface="Arial" pitchFamily="34" charset="-122"/>
+                <a:cs typeface="Arial" pitchFamily="34" charset="-120"/>
+              </a:rPr>
+              <a:t>“ORAFOL’s laminating film line for outdoor graphics caught my attention, especially since I couldn’t find a named protective overlaminate partner in your public materials.”</a:t>
+            </a:r>
+            <a:endParaRPr lang="en-US" sz="1200" dirty="0"/>
+          </a:p>
+        </p:txBody>
+      </p:sp>
+      <p:sp>
+        <p:nvSpPr>
+          <p:cNvPr id="8" name="Shape 6"/>
+          <p:cNvSpPr/>
+          <p:nvPr/>
+        </p:nvSpPr>
+        <p:spPr>
+          <a:xfrm>
+            <a:off x="4389120" y="1783080"/>
+            <a:ext cx="3291840" cy="3246120"/>
+          </a:xfrm>
+          <a:prstGeom prst="rect">
+            <a:avLst/>
+          </a:prstGeom>
+          <a:solidFill>
+            <a:srgbClr val="F2F3F0"/>
+          </a:solidFill>
+          <a:ln w="9525">
+            <a:solidFill>
+              <a:srgbClr val="D6D9D3"/>
+            </a:solidFill>
+            <a:prstDash val="solid"/>
+          </a:ln>
+        </p:spPr>
+      </p:sp>
+      <p:sp>
+        <p:nvSpPr>
+          <p:cNvPr id="9" name="Text 7"/>
+          <p:cNvSpPr/>
+          <p:nvPr/>
+        </p:nvSpPr>
+        <p:spPr>
+          <a:xfrm>
+            <a:off x="4645152" y="1993392"/>
+            <a:ext cx="2834640" cy="274320"/>
+          </a:xfrm>
+          <a:prstGeom prst="rect">
+            <a:avLst/>
+          </a:prstGeom>
+          <a:noFill/>
+          <a:ln/>
+        </p:spPr>
+        <p:txBody>
+          <a:bodyPr wrap="square" lIns="0" tIns="0" rIns="0" bIns="0" rtlCol="0" anchor="ctr"/>
+          <a:lstStyle/>
+          <a:p>
+            <a:pPr indent="0" marL="0">
+              <a:buNone/>
+            </a:pPr>
+            <a:r>
+              <a:rPr lang="en-US" sz="950" spc="120" kern="0" dirty="0">
+                <a:solidFill>
+                  <a:srgbClr val="4B3BD6"/>
+                </a:solidFill>
+                <a:latin typeface="Courier New" pitchFamily="34" charset="0"/>
+                <a:ea typeface="Courier New" pitchFamily="34" charset="-122"/>
+                <a:cs typeface="Courier New" pitchFamily="34" charset="-120"/>
+              </a:rPr>
+              <a:t>DURABILITY GAP</a:t>
+            </a:r>
+            <a:endParaRPr lang="en-US" sz="950" dirty="0"/>
+          </a:p>
+        </p:txBody>
+      </p:sp>
+      <p:sp>
+        <p:nvSpPr>
+          <p:cNvPr id="10" name="Text 8"/>
+          <p:cNvSpPr/>
+          <p:nvPr/>
+        </p:nvSpPr>
+        <p:spPr>
+          <a:xfrm>
+            <a:off x="4645152" y="2286000"/>
+            <a:ext cx="2834640" cy="292608"/>
+          </a:xfrm>
+          <a:prstGeom prst="rect">
+            <a:avLst/>
+          </a:prstGeom>
+          <a:noFill/>
+          <a:ln/>
+        </p:spPr>
+        <p:txBody>
+          <a:bodyPr wrap="square" lIns="0" tIns="0" rIns="0" bIns="0" rtlCol="0" anchor="ctr"/>
+          <a:lstStyle/>
+          <a:p>
+            <a:pPr indent="0" marL="0">
+              <a:buNone/>
+            </a:pPr>
+            <a:r>
+              <a:rPr lang="en-US" sz="1500" b="1" dirty="0">
+                <a:solidFill>
+                  <a:srgbClr val="14161A"/>
+                </a:solidFill>
+                <a:latin typeface="Arial" pitchFamily="34" charset="0"/>
+                <a:ea typeface="Arial" pitchFamily="34" charset="-122"/>
+                <a:cs typeface="Arial" pitchFamily="34" charset="-120"/>
+              </a:rPr>
+              <a:t>Quality Media</a:t>
+            </a:r>
+            <a:endParaRPr lang="en-US" sz="1500" dirty="0"/>
+          </a:p>
+        </p:txBody>
+      </p:sp>
+      <p:sp>
+        <p:nvSpPr>
+          <p:cNvPr id="11" name="Text 9"/>
+          <p:cNvSpPr/>
+          <p:nvPr/>
+        </p:nvSpPr>
+        <p:spPr>
+          <a:xfrm>
+            <a:off x="4645152" y="2670048"/>
+            <a:ext cx="2788920" cy="2194560"/>
+          </a:xfrm>
+          <a:prstGeom prst="rect">
+            <a:avLst/>
+          </a:prstGeom>
+          <a:noFill/>
+          <a:ln/>
+        </p:spPr>
+        <p:txBody>
+          <a:bodyPr wrap="square" lIns="0" tIns="0" rIns="0" bIns="0" rtlCol="0" anchor="ctr"/>
+          <a:lstStyle/>
+          <a:p>
+            <a:pPr indent="0" marL="0">
+              <a:lnSpc>
+                <a:spcPts val="1650"/>
+              </a:lnSpc>
+              <a:buNone/>
+            </a:pPr>
+            <a:r>
+              <a:rPr lang="en-US" sz="1200" dirty="0">
+                <a:solidFill>
+                  <a:srgbClr val="4A5058"/>
+                </a:solidFill>
+                <a:latin typeface="Arial" pitchFamily="34" charset="0"/>
+                <a:ea typeface="Arial" pitchFamily="34" charset="-122"/>
+                <a:cs typeface="Arial" pitchFamily="34" charset="-120"/>
+              </a:rPr>
+              <a:t>“Your wrap films are rated for 12-year durability. The gap between a good overlaminate and a great one shows up in gloss retention after year eight, not in the first-year data sheet.”</a:t>
+            </a:r>
+            <a:endParaRPr lang="en-US" sz="1200" dirty="0"/>
+          </a:p>
+        </p:txBody>
+      </p:sp>
+      <p:sp>
+        <p:nvSpPr>
+          <p:cNvPr id="12" name="Shape 10"/>
+          <p:cNvSpPr/>
+          <p:nvPr/>
+        </p:nvSpPr>
+        <p:spPr>
+          <a:xfrm>
+            <a:off x="8001000" y="1783080"/>
+            <a:ext cx="3291840" cy="3246120"/>
+          </a:xfrm>
+          <a:prstGeom prst="rect">
+            <a:avLst/>
+          </a:prstGeom>
+          <a:solidFill>
+            <a:srgbClr val="F2F3F0"/>
+          </a:solidFill>
+          <a:ln w="9525">
+            <a:solidFill>
+              <a:srgbClr val="D6D9D3"/>
+            </a:solidFill>
+            <a:prstDash val="solid"/>
+          </a:ln>
+        </p:spPr>
+      </p:sp>
+      <p:sp>
+        <p:nvSpPr>
+          <p:cNvPr id="13" name="Text 11"/>
+          <p:cNvSpPr/>
+          <p:nvPr/>
+        </p:nvSpPr>
+        <p:spPr>
+          <a:xfrm>
+            <a:off x="8257032" y="1993392"/>
+            <a:ext cx="2834640" cy="274320"/>
+          </a:xfrm>
+          <a:prstGeom prst="rect">
+            <a:avLst/>
+          </a:prstGeom>
+          <a:noFill/>
+          <a:ln/>
+        </p:spPr>
+        <p:txBody>
+          <a:bodyPr wrap="square" lIns="0" tIns="0" rIns="0" bIns="0" rtlCol="0" anchor="ctr"/>
+          <a:lstStyle/>
+          <a:p>
+            <a:pPr indent="0" marL="0">
+              <a:buNone/>
+            </a:pPr>
+            <a:r>
+              <a:rPr lang="en-US" sz="950" spc="120" kern="0" dirty="0">
+                <a:solidFill>
+                  <a:srgbClr val="4B3BD6"/>
+                </a:solidFill>
+                <a:latin typeface="Courier New" pitchFamily="34" charset="0"/>
+                <a:ea typeface="Courier New" pitchFamily="34" charset="-122"/>
+                <a:cs typeface="Courier New" pitchFamily="34" charset="-120"/>
+              </a:rPr>
+              <a:t>DISPLACEMENT</a:t>
+            </a:r>
+            <a:endParaRPr lang="en-US" sz="950" dirty="0"/>
+          </a:p>
+        </p:txBody>
+      </p:sp>
+      <p:sp>
+        <p:nvSpPr>
+          <p:cNvPr id="14" name="Text 12"/>
+          <p:cNvSpPr/>
+          <p:nvPr/>
+        </p:nvSpPr>
+        <p:spPr>
+          <a:xfrm>
+            <a:off x="8257032" y="2286000"/>
+            <a:ext cx="2834640" cy="292608"/>
+          </a:xfrm>
+          <a:prstGeom prst="rect">
+            <a:avLst/>
+          </a:prstGeom>
+          <a:noFill/>
+          <a:ln/>
+        </p:spPr>
+        <p:txBody>
+          <a:bodyPr wrap="square" lIns="0" tIns="0" rIns="0" bIns="0" rtlCol="0" anchor="ctr"/>
+          <a:lstStyle/>
+          <a:p>
+            <a:pPr indent="0" marL="0">
+              <a:buNone/>
+            </a:pPr>
+            <a:r>
+              <a:rPr lang="en-US" sz="1500" b="1" dirty="0">
+                <a:solidFill>
+                  <a:srgbClr val="14161A"/>
+                </a:solidFill>
+                <a:latin typeface="Arial" pitchFamily="34" charset="0"/>
+                <a:ea typeface="Arial" pitchFamily="34" charset="-122"/>
+                <a:cs typeface="Arial" pitchFamily="34" charset="-120"/>
+              </a:rPr>
+              <a:t>3M Commercial Graphics</a:t>
+            </a:r>
+            <a:endParaRPr lang="en-US" sz="1500" dirty="0"/>
+          </a:p>
+        </p:txBody>
+      </p:sp>
+      <p:sp>
+        <p:nvSpPr>
+          <p:cNvPr id="15" name="Text 13"/>
+          <p:cNvSpPr/>
+          <p:nvPr/>
+        </p:nvSpPr>
+        <p:spPr>
+          <a:xfrm>
+            <a:off x="8257032" y="2670048"/>
+            <a:ext cx="2788920" cy="2194560"/>
+          </a:xfrm>
+          <a:prstGeom prst="rect">
+            <a:avLst/>
+          </a:prstGeom>
+          <a:noFill/>
+          <a:ln/>
+        </p:spPr>
+        <p:txBody>
+          <a:bodyPr wrap="square" lIns="0" tIns="0" rIns="0" bIns="0" rtlCol="0" anchor="ctr"/>
+          <a:lstStyle/>
+          <a:p>
+            <a:pPr indent="0" marL="0">
+              <a:lnSpc>
+                <a:spcPts val="1650"/>
+              </a:lnSpc>
+              <a:buNone/>
+            </a:pPr>
+            <a:r>
+              <a:rPr lang="en-US" sz="1200" dirty="0">
+                <a:solidFill>
+                  <a:srgbClr val="4A5058"/>
+                </a:solidFill>
+                <a:latin typeface="Arial" pitchFamily="34" charset="0"/>
+                <a:ea typeface="Arial" pitchFamily="34" charset="-122"/>
+                <a:cs typeface="Arial" pitchFamily="34" charset="-120"/>
+              </a:rPr>
+              <a:t>“The UV ceiling of acrylic overlaminates versus PVF is worth a look. … No need to jump on a call, just let me know if useful.”</a:t>
+            </a:r>
+            <a:endParaRPr lang="en-US" sz="1200" dirty="0"/>
+          </a:p>
+        </p:txBody>
+      </p:sp>
+      <p:sp>
+        <p:nvSpPr>
+          <p:cNvPr id="16" name="Text 14"/>
+          <p:cNvSpPr/>
+          <p:nvPr/>
+        </p:nvSpPr>
+        <p:spPr>
+          <a:xfrm>
+            <a:off x="777240" y="5257800"/>
+            <a:ext cx="10515600" cy="457200"/>
+          </a:xfrm>
+          <a:prstGeom prst="rect">
+            <a:avLst/>
+          </a:prstGeom>
+          <a:noFill/>
+          <a:ln/>
+        </p:spPr>
+        <p:txBody>
+          <a:bodyPr wrap="square" lIns="0" tIns="0" rIns="0" bIns="0" rtlCol="0" anchor="ctr"/>
+          <a:lstStyle/>
+          <a:p>
+            <a:pPr indent="0" marL="0">
+              <a:lnSpc>
+                <a:spcPts val="2000"/>
+              </a:lnSpc>
+              <a:buNone/>
+            </a:pPr>
+            <a:r>
+              <a:rPr lang="en-US" sz="1450" dirty="0">
+                <a:solidFill>
+                  <a:srgbClr val="14161A"/>
+                </a:solidFill>
+                <a:latin typeface="Arial" pitchFamily="34" charset="0"/>
+                <a:ea typeface="Arial" pitchFamily="34" charset="-122"/>
+                <a:cs typeface="Arial" pitchFamily="34" charset="-120"/>
+              </a:rPr>
+              <a:t>None of these were templated. Each opening comes from a signal found during enrichment, and every claim traces to a source URL a rep can click.</a:t>
+            </a:r>
+            <a:endParaRPr lang="en-US" sz="1450" dirty="0"/>
+          </a:p>
+        </p:txBody>
+      </p:sp>
+      <p:sp>
+        <p:nvSpPr>
+          <p:cNvPr id="17" name="Text 15"/>
+          <p:cNvSpPr/>
+          <p:nvPr/>
+        </p:nvSpPr>
+        <p:spPr>
+          <a:xfrm>
+            <a:off x="777240" y="5806440"/>
+            <a:ext cx="10515600" cy="457200"/>
+          </a:xfrm>
+          <a:prstGeom prst="rect">
+            <a:avLst/>
+          </a:prstGeom>
+          <a:noFill/>
+          <a:ln/>
+        </p:spPr>
+        <p:txBody>
+          <a:bodyPr wrap="square" lIns="0" tIns="0" rIns="0" bIns="0" rtlCol="0" anchor="ctr"/>
+          <a:lstStyle/>
+          <a:p>
+            <a:pPr indent="0" marL="0">
+              <a:lnSpc>
+                <a:spcPts val="1800"/>
+              </a:lnSpc>
+              <a:buNone/>
+            </a:pPr>
+            <a:r>
+              <a:rPr lang="en-US" sz="1300" i="1" dirty="0">
+                <a:solidFill>
+                  <a:srgbClr val="7D848D"/>
+                </a:solidFill>
+                <a:latin typeface="Arial" pitchFamily="34" charset="0"/>
+                <a:ea typeface="Arial" pitchFamily="34" charset="-122"/>
+                <a:cs typeface="Arial" pitchFamily="34" charset="-120"/>
+              </a:rPr>
+              <a:t>A rep opens a queue of these, edits or approves, and sends. The system does the research and the first draft; the judgement stays human.</a:t>
+            </a:r>
+            <a:endParaRPr lang="en-US" sz="1300" dirty="0"/>
+          </a:p>
+        </p:txBody>
+      </p:sp>
+    </p:spTree>
+  </p:cSld>
+  <p:clrMapOvr>
+    <a:masterClrMapping/>
+  </p:clrMapOvr>
+</p:sld>
+</file>
+
+<file path=ppt/slides/slide5.xml><?xml version="1.0" encoding="utf-8"?>
+<p:sld xmlns:a="http://schemas.openxmlformats.org/drawingml/2006/main" xmlns:r="http://schemas.openxmlformats.org/officeDocument/2006/relationships" xmlns:p="http://schemas.openxmlformats.org/presentationml/2006/main">
+  <p:cSld name="Slide 5">
+    <p:bg>
+      <p:bgPr>
+        <a:solidFill>
           <a:srgbClr val="F2F3F0"/>
         </a:solidFill>
       </p:bgPr>
@@ -4036,9 +4754,9 @@
 </p:sld>
 </file>
 
-<file path=ppt/slides/slide5.xml><?xml version="1.0" encoding="utf-8"?>
+<file path=ppt/slides/slide6.xml><?xml version="1.0" encoding="utf-8"?>
 <p:sld xmlns:a="http://schemas.openxmlformats.org/drawingml/2006/main" xmlns:r="http://schemas.openxmlformats.org/officeDocument/2006/relationships" xmlns:p="http://schemas.openxmlformats.org/presentationml/2006/main">
-  <p:cSld name="Slide 5">
+  <p:cSld name="Slide 6">
     <p:bg>
       <p:bgPr>
         <a:solidFill>
@@ -4588,9 +5306,9 @@
 </p:sld>
 </file>
 
-<file path=ppt/slides/slide6.xml><?xml version="1.0" encoding="utf-8"?>
+<file path=ppt/slides/slide7.xml><?xml version="1.0" encoding="utf-8"?>
 <p:sld xmlns:a="http://schemas.openxmlformats.org/drawingml/2006/main" xmlns:r="http://schemas.openxmlformats.org/officeDocument/2006/relationships" xmlns:p="http://schemas.openxmlformats.org/presentationml/2006/main">
-  <p:cSld name="Slide 6">
+  <p:cSld name="Slide 7">
     <p:bg>
       <p:bgPr>
         <a:solidFill>
@@ -5214,9 +5932,9 @@
 </p:sld>
 </file>
 
-<file path=ppt/slides/slide7.xml><?xml version="1.0" encoding="utf-8"?>
+<file path=ppt/slides/slide8.xml><?xml version="1.0" encoding="utf-8"?>
 <p:sld xmlns:a="http://schemas.openxmlformats.org/drawingml/2006/main" xmlns:r="http://schemas.openxmlformats.org/officeDocument/2006/relationships" xmlns:p="http://schemas.openxmlformats.org/presentationml/2006/main">
-  <p:cSld name="Slide 7">
+  <p:cSld name="Slide 8">
     <p:bg>
       <p:bgPr>
         <a:solidFill>

</xml_diff>